<commit_message>
chore: remove chatbot notebook and update presentation
</commit_message>
<xml_diff>
--- a/presentations/EHR_Pre_Consultation_System_CSE499A.pptx
+++ b/presentations/EHR_Pre_Consultation_System_CSE499A.pptx
@@ -5,7 +5,7 @@
     <p:sldMasterId id="2147483648" r:id="rId1"/>
   </p:sldMasterIdLst>
   <p:notesMasterIdLst>
-    <p:notesMasterId r:id="rId11"/>
+    <p:notesMasterId r:id="rId10"/>
   </p:notesMasterIdLst>
   <p:sldIdLst>
     <p:sldId id="256" r:id="rId2"/>
@@ -16,7 +16,6 @@
     <p:sldId id="261" r:id="rId7"/>
     <p:sldId id="262" r:id="rId8"/>
     <p:sldId id="263" r:id="rId9"/>
-    <p:sldId id="264" r:id="rId10"/>
   </p:sldIdLst>
   <p:sldSz cx="12192000" cy="6858000"/>
   <p:notesSz cx="6858000" cy="12192000"/>
@@ -1792,90 +1791,6 @@
 </p:notes>
 </file>
 
-<file path=ppt/notesSlides/notesSlide9.xml><?xml version="1.0" encoding="utf-8"?>
-<p:notes xmlns:a="http://schemas.openxmlformats.org/drawingml/2006/main" xmlns:r="http://schemas.openxmlformats.org/officeDocument/2006/relationships" xmlns:p="http://schemas.openxmlformats.org/presentationml/2006/main">
-  <p:cSld>
-    <p:spTree>
-      <p:nvGrpSpPr>
-        <p:cNvPr id="1" name=""/>
-        <p:cNvGrpSpPr/>
-        <p:nvPr/>
-      </p:nvGrpSpPr>
-      <p:grpSpPr>
-        <a:xfrm>
-          <a:off x="0" y="0"/>
-          <a:ext cx="0" cy="0"/>
-          <a:chOff x="0" y="0"/>
-          <a:chExt cx="0" cy="0"/>
-        </a:xfrm>
-      </p:grpSpPr>
-      <p:sp>
-        <p:nvSpPr>
-          <p:cNvPr id="2" name="Slide Image Placeholder 1"/>
-          <p:cNvSpPr>
-            <a:spLocks noGrp="1" noRot="1" noChangeAspect="1"/>
-          </p:cNvSpPr>
-          <p:nvPr>
-            <p:ph type="sldImg"/>
-          </p:nvPr>
-        </p:nvSpPr>
-        <p:spPr/>
-      </p:sp>
-      <p:sp>
-        <p:nvSpPr>
-          <p:cNvPr id="3" name="Notes Placeholder 2"/>
-          <p:cNvSpPr>
-            <a:spLocks noGrp="1"/>
-          </p:cNvSpPr>
-          <p:nvPr>
-            <p:ph type="body" idx="1"/>
-          </p:nvPr>
-        </p:nvSpPr>
-        <p:spPr/>
-        <p:txBody>
-          <a:bodyPr/>
-          <a:lstStyle/>
-          <a:p>
-            <a:endParaRPr lang="en-US" dirty="0"/>
-          </a:p>
-        </p:txBody>
-      </p:sp>
-      <p:sp>
-        <p:nvSpPr>
-          <p:cNvPr id="4" name="Slide Number Placeholder 3"/>
-          <p:cNvSpPr>
-            <a:spLocks noGrp="1"/>
-          </p:cNvSpPr>
-          <p:nvPr>
-            <p:ph type="sldNum" sz="quarter" idx="10"/>
-          </p:nvPr>
-        </p:nvSpPr>
-        <p:spPr/>
-        <p:txBody>
-          <a:bodyPr/>
-          <a:lstStyle/>
-          <a:p>
-            <a:fld id="{F7021451-1387-4CA6-816F-3879F97B5CBC}" type="slidenum">
-              <a:rPr lang="en-US"/>
-              <a:t>9</a:t>
-            </a:fld>
-            <a:endParaRPr lang="en-US"/>
-          </a:p>
-        </p:txBody>
-      </p:sp>
-    </p:spTree>
-    <p:extLst>
-      <p:ext uri="{BB962C8B-B14F-4D97-AF65-F5344CB8AC3E}">
-        <p14:creationId xmlns:p14="http://schemas.microsoft.com/office/powerpoint/2010/main" val="1024086991"/>
-      </p:ext>
-    </p:extLst>
-  </p:cSld>
-  <p:clrMapOvr>
-    <a:masterClrMapping/>
-  </p:clrMapOvr>
-</p:notes>
-</file>
-
 <file path=ppt/slideLayouts/slideLayout1.xml><?xml version="1.0" encoding="utf-8"?>
 <p:sldLayout xmlns:a="http://schemas.openxmlformats.org/drawingml/2006/main" xmlns:r="http://schemas.openxmlformats.org/officeDocument/2006/relationships" xmlns:p="http://schemas.openxmlformats.org/presentationml/2006/main" preserve="1">
   <p:cSld name="DEFAULT">
@@ -2694,7 +2609,7 @@
       <p:sp>
         <p:nvSpPr>
           <p:cNvPr id="12" name="Text 10">
-            <a:hlinkClick r:id=""/>
+            <a:hlinkClick r:id="" action="ppaction://noaction"/>
           </p:cNvPr>
           <p:cNvSpPr/>
           <p:nvPr/>
@@ -2725,7 +2640,7 @@
                 <a:latin typeface="Calibri" pitchFamily="34" charset="0"/>
                 <a:ea typeface="Calibri" pitchFamily="34" charset="-122"/>
                 <a:cs typeface="Calibri" pitchFamily="34" charset="-120"/>
-                <a:hlinkClick r:id="">
+                <a:hlinkClick r:id="" action="ppaction://noaction">
                   <a:extLst>
                     <a:ext uri="{A12FA001-AC4F-418D-AE19-62706E023703}">
                       <ahyp:hlinkClr xmlns:ahyp="http://schemas.microsoft.com/office/drawing/2018/hyperlinkcolor" val="tx"/>
@@ -2743,7 +2658,7 @@
                 <a:latin typeface="Calibri" pitchFamily="34" charset="0"/>
                 <a:ea typeface="Calibri" pitchFamily="34" charset="-122"/>
                 <a:cs typeface="Calibri" pitchFamily="34" charset="-120"/>
-                <a:hlinkClick r:id="">
+                <a:hlinkClick r:id="" action="ppaction://noaction">
                   <a:extLst>
                     <a:ext uri="{A12FA001-AC4F-418D-AE19-62706E023703}">
                       <ahyp:hlinkClr xmlns:ahyp="http://schemas.microsoft.com/office/drawing/2018/hyperlinkcolor" val="tx"/>
@@ -2761,7 +2676,7 @@
                 <a:latin typeface="Calibri" pitchFamily="34" charset="0"/>
                 <a:ea typeface="Calibri" pitchFamily="34" charset="-122"/>
                 <a:cs typeface="Calibri" pitchFamily="34" charset="-120"/>
-                <a:hlinkClick r:id="">
+                <a:hlinkClick r:id="" action="ppaction://noaction">
                   <a:extLst>
                     <a:ext uri="{A12FA001-AC4F-418D-AE19-62706E023703}">
                       <ahyp:hlinkClr xmlns:ahyp="http://schemas.microsoft.com/office/drawing/2018/hyperlinkcolor" val="tx"/>
@@ -2778,7 +2693,7 @@
       <p:sp>
         <p:nvSpPr>
           <p:cNvPr id="13" name="Text 11">
-            <a:hlinkClick r:id=""/>
+            <a:hlinkClick r:id="" action="ppaction://noaction"/>
           </p:cNvPr>
           <p:cNvSpPr/>
           <p:nvPr/>
@@ -2809,7 +2724,7 @@
                 <a:latin typeface="Calibri" pitchFamily="34" charset="0"/>
                 <a:ea typeface="Calibri" pitchFamily="34" charset="-122"/>
                 <a:cs typeface="Calibri" pitchFamily="34" charset="-120"/>
-                <a:hlinkClick r:id="">
+                <a:hlinkClick r:id="" action="ppaction://noaction">
                   <a:extLst>
                     <a:ext uri="{A12FA001-AC4F-418D-AE19-62706E023703}">
                       <ahyp:hlinkClr xmlns:ahyp="http://schemas.microsoft.com/office/drawing/2018/hyperlinkcolor" val="tx"/>
@@ -2827,7 +2742,7 @@
                 <a:latin typeface="Calibri" pitchFamily="34" charset="0"/>
                 <a:ea typeface="Calibri" pitchFamily="34" charset="-122"/>
                 <a:cs typeface="Calibri" pitchFamily="34" charset="-120"/>
-                <a:hlinkClick r:id="">
+                <a:hlinkClick r:id="" action="ppaction://noaction">
                   <a:extLst>
                     <a:ext uri="{A12FA001-AC4F-418D-AE19-62706E023703}">
                       <ahyp:hlinkClr xmlns:ahyp="http://schemas.microsoft.com/office/drawing/2018/hyperlinkcolor" val="tx"/>
@@ -2845,7 +2760,7 @@
                 <a:latin typeface="Calibri" pitchFamily="34" charset="0"/>
                 <a:ea typeface="Calibri" pitchFamily="34" charset="-122"/>
                 <a:cs typeface="Calibri" pitchFamily="34" charset="-120"/>
-                <a:hlinkClick r:id="">
+                <a:hlinkClick r:id="" action="ppaction://noaction">
                   <a:extLst>
                     <a:ext uri="{A12FA001-AC4F-418D-AE19-62706E023703}">
                       <ahyp:hlinkClr xmlns:ahyp="http://schemas.microsoft.com/office/drawing/2018/hyperlinkcolor" val="tx"/>
@@ -11811,2301 +11726,6 @@
               <a:t>   ·   full notebooks, dataset log, and evaluation scripts available on the project repository</a:t>
             </a:r>
             <a:endParaRPr lang="en-US" sz="800" dirty="0"/>
-          </a:p>
-        </p:txBody>
-      </p:sp>
-    </p:spTree>
-  </p:cSld>
-  <p:clrMapOvr>
-    <a:masterClrMapping/>
-  </p:clrMapOvr>
-</p:sld>
-</file>
-
-<file path=ppt/slides/slide9.xml><?xml version="1.0" encoding="utf-8"?>
-<p:sld xmlns:a="http://schemas.openxmlformats.org/drawingml/2006/main" xmlns:r="http://schemas.openxmlformats.org/officeDocument/2006/relationships" xmlns:p="http://schemas.openxmlformats.org/presentationml/2006/main">
-  <p:cSld name="Slide 9">
-    <p:bg>
-      <p:bgPr>
-        <a:solidFill>
-          <a:srgbClr val="FFFFFF"/>
-        </a:solidFill>
-        <a:effectLst/>
-      </p:bgPr>
-    </p:bg>
-    <p:spTree>
-      <p:nvGrpSpPr>
-        <p:cNvPr id="1" name=""/>
-        <p:cNvGrpSpPr/>
-        <p:nvPr/>
-      </p:nvGrpSpPr>
-      <p:grpSpPr>
-        <a:xfrm>
-          <a:off x="0" y="0"/>
-          <a:ext cx="0" cy="0"/>
-          <a:chOff x="0" y="0"/>
-          <a:chExt cx="0" cy="0"/>
-        </a:xfrm>
-      </p:grpSpPr>
-      <p:sp>
-        <p:nvSpPr>
-          <p:cNvPr id="2" name="Shape 0"/>
-          <p:cNvSpPr/>
-          <p:nvPr/>
-        </p:nvSpPr>
-        <p:spPr>
-          <a:xfrm>
-            <a:off x="0" y="0"/>
-            <a:ext cx="164592" cy="6858000"/>
-          </a:xfrm>
-          <a:prstGeom prst="rect">
-            <a:avLst/>
-          </a:prstGeom>
-          <a:solidFill>
-            <a:srgbClr val="0F2747"/>
-          </a:solidFill>
-          <a:ln/>
-        </p:spPr>
-      </p:sp>
-      <p:sp>
-        <p:nvSpPr>
-          <p:cNvPr id="3" name="Text 1"/>
-          <p:cNvSpPr/>
-          <p:nvPr/>
-        </p:nvSpPr>
-        <p:spPr>
-          <a:xfrm>
-            <a:off x="5760720" y="292608"/>
-            <a:ext cx="6126480" cy="274320"/>
-          </a:xfrm>
-          <a:prstGeom prst="rect">
-            <a:avLst/>
-          </a:prstGeom>
-          <a:noFill/>
-          <a:ln/>
-        </p:spPr>
-        <p:txBody>
-          <a:bodyPr wrap="square" lIns="0" tIns="0" rIns="0" bIns="0" rtlCol="0" anchor="t"/>
-          <a:lstStyle/>
-          <a:p>
-            <a:pPr marL="0" indent="0" algn="r">
-              <a:buNone/>
-            </a:pPr>
-            <a:r>
-              <a:rPr lang="en-US" sz="1000" b="1" kern="0" spc="400" dirty="0">
-                <a:solidFill>
-                  <a:srgbClr val="94A3B8"/>
-                </a:solidFill>
-                <a:latin typeface="Calibri" pitchFamily="34" charset="0"/>
-                <a:ea typeface="Calibri" pitchFamily="34" charset="-122"/>
-                <a:cs typeface="Calibri" pitchFamily="34" charset="-120"/>
-              </a:rPr>
-              <a:t>RELATED WORK</a:t>
-            </a:r>
-            <a:r>
-              <a:rPr lang="en-US" sz="1000" b="1" dirty="0">
-                <a:solidFill>
-                  <a:srgbClr val="E2E8F0"/>
-                </a:solidFill>
-                <a:latin typeface="Calibri" pitchFamily="34" charset="0"/>
-                <a:ea typeface="Calibri" pitchFamily="34" charset="-122"/>
-                <a:cs typeface="Calibri" pitchFamily="34" charset="-120"/>
-              </a:rPr>
-              <a:t>   ·   </a:t>
-            </a:r>
-            <a:r>
-              <a:rPr lang="en-US" sz="1000" b="1" kern="0" spc="200" dirty="0">
-                <a:solidFill>
-                  <a:srgbClr val="0D9488"/>
-                </a:solidFill>
-                <a:latin typeface="Calibri" pitchFamily="34" charset="0"/>
-                <a:ea typeface="Calibri" pitchFamily="34" charset="-122"/>
-                <a:cs typeface="Calibri" pitchFamily="34" charset="-120"/>
-              </a:rPr>
-              <a:t>09 / 09</a:t>
-            </a:r>
-            <a:endParaRPr lang="en-US" sz="1000" dirty="0"/>
-          </a:p>
-        </p:txBody>
-      </p:sp>
-      <p:sp>
-        <p:nvSpPr>
-          <p:cNvPr id="4" name="Text 2"/>
-          <p:cNvSpPr/>
-          <p:nvPr/>
-        </p:nvSpPr>
-        <p:spPr>
-          <a:xfrm>
-            <a:off x="502920" y="640080"/>
-            <a:ext cx="10058400" cy="640080"/>
-          </a:xfrm>
-          <a:prstGeom prst="rect">
-            <a:avLst/>
-          </a:prstGeom>
-          <a:noFill/>
-          <a:ln/>
-        </p:spPr>
-        <p:txBody>
-          <a:bodyPr wrap="square" lIns="0" tIns="0" rIns="0" bIns="0" rtlCol="0" anchor="t"/>
-          <a:lstStyle/>
-          <a:p>
-            <a:pPr marL="0" indent="0" algn="l">
-              <a:buNone/>
-            </a:pPr>
-            <a:r>
-              <a:rPr lang="en-US" sz="3000" b="1" dirty="0">
-                <a:solidFill>
-                  <a:srgbClr val="0F2747"/>
-                </a:solidFill>
-                <a:latin typeface="Cambria" pitchFamily="34" charset="0"/>
-                <a:ea typeface="Cambria" pitchFamily="34" charset="-122"/>
-                <a:cs typeface="Cambria" pitchFamily="34" charset="-120"/>
-              </a:rPr>
-              <a:t>Related work &amp; project resources</a:t>
-            </a:r>
-            <a:endParaRPr lang="en-US" sz="3000" dirty="0"/>
-          </a:p>
-        </p:txBody>
-      </p:sp>
-      <p:sp>
-        <p:nvSpPr>
-          <p:cNvPr id="5" name="Text 3"/>
-          <p:cNvSpPr/>
-          <p:nvPr/>
-        </p:nvSpPr>
-        <p:spPr>
-          <a:xfrm>
-            <a:off x="502920" y="6492240"/>
-            <a:ext cx="7315200" cy="228600"/>
-          </a:xfrm>
-          <a:prstGeom prst="rect">
-            <a:avLst/>
-          </a:prstGeom>
-          <a:noFill/>
-          <a:ln/>
-        </p:spPr>
-        <p:txBody>
-          <a:bodyPr wrap="square" lIns="0" tIns="0" rIns="0" bIns="0" rtlCol="0" anchor="ctr"/>
-          <a:lstStyle/>
-          <a:p>
-            <a:pPr marL="0" indent="0" algn="l">
-              <a:buNone/>
-            </a:pPr>
-            <a:r>
-              <a:rPr lang="en-US" sz="900" dirty="0">
-                <a:solidFill>
-                  <a:srgbClr val="94A3B8"/>
-                </a:solidFill>
-                <a:latin typeface="Calibri" pitchFamily="34" charset="0"/>
-                <a:ea typeface="Calibri" pitchFamily="34" charset="-122"/>
-                <a:cs typeface="Calibri" pitchFamily="34" charset="-120"/>
-              </a:rPr>
-              <a:t>EHR Pre-Consultation System  ·  CSE499A  ·  NSU</a:t>
-            </a:r>
-            <a:endParaRPr lang="en-US" sz="900" dirty="0"/>
-          </a:p>
-        </p:txBody>
-      </p:sp>
-      <p:sp>
-        <p:nvSpPr>
-          <p:cNvPr id="6" name="Text 4"/>
-          <p:cNvSpPr/>
-          <p:nvPr/>
-        </p:nvSpPr>
-        <p:spPr>
-          <a:xfrm>
-            <a:off x="502920" y="1325880"/>
-            <a:ext cx="11155680" cy="274320"/>
-          </a:xfrm>
-          <a:prstGeom prst="rect">
-            <a:avLst/>
-          </a:prstGeom>
-          <a:noFill/>
-          <a:ln/>
-        </p:spPr>
-        <p:txBody>
-          <a:bodyPr wrap="square" lIns="0" tIns="0" rIns="0" bIns="0" rtlCol="0" anchor="ctr"/>
-          <a:lstStyle/>
-          <a:p>
-            <a:pPr marL="0" indent="0">
-              <a:buNone/>
-            </a:pPr>
-            <a:r>
-              <a:rPr lang="en-US" sz="1300" i="1" dirty="0">
-                <a:solidFill>
-                  <a:srgbClr val="475569"/>
-                </a:solidFill>
-                <a:latin typeface="Calibri" pitchFamily="34" charset="0"/>
-                <a:ea typeface="Calibri" pitchFamily="34" charset="-122"/>
-                <a:cs typeface="Calibri" pitchFamily="34" charset="-120"/>
-              </a:rPr>
-              <a:t>Foundational research the project builds on, plus where to find our code and dataset.</a:t>
-            </a:r>
-            <a:endParaRPr lang="en-US" sz="1300" dirty="0"/>
-          </a:p>
-        </p:txBody>
-      </p:sp>
-      <p:sp>
-        <p:nvSpPr>
-          <p:cNvPr id="7" name="Shape 5"/>
-          <p:cNvSpPr/>
-          <p:nvPr/>
-        </p:nvSpPr>
-        <p:spPr>
-          <a:xfrm>
-            <a:off x="502920" y="1737360"/>
-            <a:ext cx="5486400" cy="960120"/>
-          </a:xfrm>
-          <a:prstGeom prst="rect">
-            <a:avLst/>
-          </a:prstGeom>
-          <a:solidFill>
-            <a:srgbClr val="0F2747"/>
-          </a:solidFill>
-          <a:ln/>
-        </p:spPr>
-      </p:sp>
-      <p:sp>
-        <p:nvSpPr>
-          <p:cNvPr id="8" name="Shape 6"/>
-          <p:cNvSpPr/>
-          <p:nvPr/>
-        </p:nvSpPr>
-        <p:spPr>
-          <a:xfrm>
-            <a:off x="502920" y="1737360"/>
-            <a:ext cx="54864" cy="960120"/>
-          </a:xfrm>
-          <a:prstGeom prst="rect">
-            <a:avLst/>
-          </a:prstGeom>
-          <a:solidFill>
-            <a:srgbClr val="5EEAD4"/>
-          </a:solidFill>
-          <a:ln/>
-        </p:spPr>
-      </p:sp>
-      <p:sp>
-        <p:nvSpPr>
-          <p:cNvPr id="9" name="Shape 7"/>
-          <p:cNvSpPr/>
-          <p:nvPr/>
-        </p:nvSpPr>
-        <p:spPr>
-          <a:xfrm>
-            <a:off x="713232" y="1920240"/>
-            <a:ext cx="594360" cy="594360"/>
-          </a:xfrm>
-          <a:prstGeom prst="ellipse">
-            <a:avLst/>
-          </a:prstGeom>
-          <a:solidFill>
-            <a:srgbClr val="0D9488"/>
-          </a:solidFill>
-          <a:ln/>
-        </p:spPr>
-      </p:sp>
-      <p:pic>
-        <p:nvPicPr>
-          <p:cNvPr id="10" name="Image 0" descr="preencoded.png"/>
-          <p:cNvPicPr>
-            <a:picLocks noChangeAspect="1"/>
-          </p:cNvPicPr>
-          <p:nvPr/>
-        </p:nvPicPr>
-        <p:blipFill>
-          <a:blip r:embed="rId3"/>
-          <a:stretch>
-            <a:fillRect/>
-          </a:stretch>
-        </p:blipFill>
-        <p:spPr>
-          <a:xfrm>
-            <a:off x="832104" y="2039112"/>
-            <a:ext cx="365760" cy="365760"/>
-          </a:xfrm>
-          <a:prstGeom prst="rect">
-            <a:avLst/>
-          </a:prstGeom>
-        </p:spPr>
-      </p:pic>
-      <p:sp>
-        <p:nvSpPr>
-          <p:cNvPr id="11" name="Text 8"/>
-          <p:cNvSpPr/>
-          <p:nvPr/>
-        </p:nvSpPr>
-        <p:spPr>
-          <a:xfrm>
-            <a:off x="1463040" y="1883664"/>
-            <a:ext cx="4389120" cy="201168"/>
-          </a:xfrm>
-          <a:prstGeom prst="rect">
-            <a:avLst/>
-          </a:prstGeom>
-          <a:noFill/>
-          <a:ln/>
-        </p:spPr>
-        <p:txBody>
-          <a:bodyPr wrap="square" lIns="0" tIns="0" rIns="0" bIns="0" rtlCol="0" anchor="ctr"/>
-          <a:lstStyle/>
-          <a:p>
-            <a:pPr marL="0" indent="0">
-              <a:buNone/>
-            </a:pPr>
-            <a:r>
-              <a:rPr lang="en-US" sz="1000" b="1" kern="0" spc="400" dirty="0">
-                <a:solidFill>
-                  <a:srgbClr val="5EEAD4"/>
-                </a:solidFill>
-                <a:latin typeface="Calibri" pitchFamily="34" charset="0"/>
-                <a:ea typeface="Calibri" pitchFamily="34" charset="-122"/>
-                <a:cs typeface="Calibri" pitchFamily="34" charset="-120"/>
-              </a:rPr>
-              <a:t>PROJECT REPOSITORY · CODE</a:t>
-            </a:r>
-            <a:endParaRPr lang="en-US" sz="1000" dirty="0"/>
-          </a:p>
-        </p:txBody>
-      </p:sp>
-      <p:sp>
-        <p:nvSpPr>
-          <p:cNvPr id="12" name="Text 9">
-            <a:hlinkClick r:id="rId4"/>
-          </p:cNvPr>
-          <p:cNvSpPr/>
-          <p:nvPr/>
-        </p:nvSpPr>
-        <p:spPr>
-          <a:xfrm>
-            <a:off x="1463040" y="2103120"/>
-            <a:ext cx="4434840" cy="274320"/>
-          </a:xfrm>
-          <a:prstGeom prst="rect">
-            <a:avLst/>
-          </a:prstGeom>
-          <a:noFill/>
-          <a:ln/>
-        </p:spPr>
-        <p:txBody>
-          <a:bodyPr wrap="square" lIns="0" tIns="0" rIns="0" bIns="0" rtlCol="0" anchor="t"/>
-          <a:lstStyle/>
-          <a:p>
-            <a:pPr marL="0" indent="0">
-              <a:buNone/>
-            </a:pPr>
-            <a:r>
-              <a:rPr lang="en-US" sz="1100" b="1" u="sng" dirty="0">
-                <a:solidFill>
-                  <a:srgbClr val="FFFFFF"/>
-                </a:solidFill>
-                <a:latin typeface="Calibri" pitchFamily="34" charset="0"/>
-                <a:ea typeface="Calibri" pitchFamily="34" charset="-122"/>
-                <a:cs typeface="Calibri" pitchFamily="34" charset="-120"/>
-                <a:hlinkClick r:id="rId4">
-                  <a:extLst>
-                    <a:ext uri="{A12FA001-AC4F-418D-AE19-62706E023703}">
-                      <ahyp:hlinkClr xmlns:ahyp="http://schemas.microsoft.com/office/drawing/2018/hyperlinkcolor" val="tx"/>
-                    </a:ext>
-                  </a:extLst>
-                </a:hlinkClick>
-              </a:rPr>
-              <a:t>github.com/RRM006/cse499-project-temp-azk-2026</a:t>
-            </a:r>
-            <a:endParaRPr lang="en-US" sz="1100" dirty="0"/>
-          </a:p>
-        </p:txBody>
-      </p:sp>
-      <p:sp>
-        <p:nvSpPr>
-          <p:cNvPr id="13" name="Text 10"/>
-          <p:cNvSpPr/>
-          <p:nvPr/>
-        </p:nvSpPr>
-        <p:spPr>
-          <a:xfrm>
-            <a:off x="1463040" y="2395728"/>
-            <a:ext cx="4434840" cy="228600"/>
-          </a:xfrm>
-          <a:prstGeom prst="rect">
-            <a:avLst/>
-          </a:prstGeom>
-          <a:noFill/>
-          <a:ln/>
-        </p:spPr>
-        <p:txBody>
-          <a:bodyPr wrap="square" lIns="0" tIns="0" rIns="0" bIns="0" rtlCol="0" anchor="ctr"/>
-          <a:lstStyle/>
-          <a:p>
-            <a:pPr marL="0" indent="0">
-              <a:buNone/>
-            </a:pPr>
-            <a:r>
-              <a:rPr lang="en-US" sz="900" i="1" dirty="0">
-                <a:solidFill>
-                  <a:srgbClr val="94A3B8"/>
-                </a:solidFill>
-                <a:latin typeface="Calibri" pitchFamily="34" charset="0"/>
-                <a:ea typeface="Calibri" pitchFamily="34" charset="-122"/>
-                <a:cs typeface="Calibri" pitchFamily="34" charset="-120"/>
-              </a:rPr>
-              <a:t>Notebooks · evaluation scripts · dataset_log · model comparison results</a:t>
-            </a:r>
-            <a:endParaRPr lang="en-US" sz="900" dirty="0"/>
-          </a:p>
-        </p:txBody>
-      </p:sp>
-      <p:sp>
-        <p:nvSpPr>
-          <p:cNvPr id="14" name="Shape 11"/>
-          <p:cNvSpPr/>
-          <p:nvPr/>
-        </p:nvSpPr>
-        <p:spPr>
-          <a:xfrm>
-            <a:off x="6172200" y="1737360"/>
-            <a:ext cx="5486400" cy="960120"/>
-          </a:xfrm>
-          <a:prstGeom prst="rect">
-            <a:avLst/>
-          </a:prstGeom>
-          <a:solidFill>
-            <a:srgbClr val="0F2747"/>
-          </a:solidFill>
-          <a:ln/>
-        </p:spPr>
-      </p:sp>
-      <p:sp>
-        <p:nvSpPr>
-          <p:cNvPr id="15" name="Shape 12"/>
-          <p:cNvSpPr/>
-          <p:nvPr/>
-        </p:nvSpPr>
-        <p:spPr>
-          <a:xfrm>
-            <a:off x="6172200" y="1737360"/>
-            <a:ext cx="54864" cy="960120"/>
-          </a:xfrm>
-          <a:prstGeom prst="rect">
-            <a:avLst/>
-          </a:prstGeom>
-          <a:solidFill>
-            <a:srgbClr val="5EEAD4"/>
-          </a:solidFill>
-          <a:ln/>
-        </p:spPr>
-      </p:sp>
-      <p:sp>
-        <p:nvSpPr>
-          <p:cNvPr id="16" name="Shape 13"/>
-          <p:cNvSpPr/>
-          <p:nvPr/>
-        </p:nvSpPr>
-        <p:spPr>
-          <a:xfrm>
-            <a:off x="6382512" y="1920240"/>
-            <a:ext cx="594360" cy="594360"/>
-          </a:xfrm>
-          <a:prstGeom prst="ellipse">
-            <a:avLst/>
-          </a:prstGeom>
-          <a:solidFill>
-            <a:srgbClr val="0D9488"/>
-          </a:solidFill>
-          <a:ln/>
-        </p:spPr>
-      </p:sp>
-      <p:pic>
-        <p:nvPicPr>
-          <p:cNvPr id="17" name="Image 1" descr="preencoded.png"/>
-          <p:cNvPicPr>
-            <a:picLocks noChangeAspect="1"/>
-          </p:cNvPicPr>
-          <p:nvPr/>
-        </p:nvPicPr>
-        <p:blipFill>
-          <a:blip r:embed="rId5"/>
-          <a:stretch>
-            <a:fillRect/>
-          </a:stretch>
-        </p:blipFill>
-        <p:spPr>
-          <a:xfrm>
-            <a:off x="6501384" y="2039112"/>
-            <a:ext cx="365760" cy="365760"/>
-          </a:xfrm>
-          <a:prstGeom prst="rect">
-            <a:avLst/>
-          </a:prstGeom>
-        </p:spPr>
-      </p:pic>
-      <p:sp>
-        <p:nvSpPr>
-          <p:cNvPr id="18" name="Text 14"/>
-          <p:cNvSpPr/>
-          <p:nvPr/>
-        </p:nvSpPr>
-        <p:spPr>
-          <a:xfrm>
-            <a:off x="7132320" y="1883664"/>
-            <a:ext cx="4389120" cy="201168"/>
-          </a:xfrm>
-          <a:prstGeom prst="rect">
-            <a:avLst/>
-          </a:prstGeom>
-          <a:noFill/>
-          <a:ln/>
-        </p:spPr>
-        <p:txBody>
-          <a:bodyPr wrap="square" lIns="0" tIns="0" rIns="0" bIns="0" rtlCol="0" anchor="ctr"/>
-          <a:lstStyle/>
-          <a:p>
-            <a:pPr marL="0" indent="0">
-              <a:buNone/>
-            </a:pPr>
-            <a:r>
-              <a:rPr lang="en-US" sz="1000" b="1" kern="0" spc="400" dirty="0">
-                <a:solidFill>
-                  <a:srgbClr val="5EEAD4"/>
-                </a:solidFill>
-                <a:latin typeface="Calibri" pitchFamily="34" charset="0"/>
-                <a:ea typeface="Calibri" pitchFamily="34" charset="-122"/>
-                <a:cs typeface="Calibri" pitchFamily="34" charset="-120"/>
-              </a:rPr>
-              <a:t>DATASET · GOOGLE DRIVE FOLDER</a:t>
-            </a:r>
-            <a:endParaRPr lang="en-US" sz="1000" dirty="0"/>
-          </a:p>
-        </p:txBody>
-      </p:sp>
-      <p:sp>
-        <p:nvSpPr>
-          <p:cNvPr id="19" name="Text 15">
-            <a:hlinkClick r:id="rId6"/>
-          </p:cNvPr>
-          <p:cNvSpPr/>
-          <p:nvPr/>
-        </p:nvSpPr>
-        <p:spPr>
-          <a:xfrm>
-            <a:off x="7132320" y="2103120"/>
-            <a:ext cx="4434840" cy="274320"/>
-          </a:xfrm>
-          <a:prstGeom prst="rect">
-            <a:avLst/>
-          </a:prstGeom>
-          <a:noFill/>
-          <a:ln/>
-        </p:spPr>
-        <p:txBody>
-          <a:bodyPr wrap="square" lIns="0" tIns="0" rIns="0" bIns="0" rtlCol="0" anchor="t"/>
-          <a:lstStyle/>
-          <a:p>
-            <a:pPr marL="0" indent="0">
-              <a:buNone/>
-            </a:pPr>
-            <a:r>
-              <a:rPr lang="en-US" sz="1100" b="1" u="sng" dirty="0">
-                <a:solidFill>
-                  <a:srgbClr val="FFFFFF"/>
-                </a:solidFill>
-                <a:latin typeface="Calibri" pitchFamily="34" charset="0"/>
-                <a:ea typeface="Calibri" pitchFamily="34" charset="-122"/>
-                <a:cs typeface="Calibri" pitchFamily="34" charset="-120"/>
-                <a:hlinkClick r:id="rId6">
-                  <a:extLst>
-                    <a:ext uri="{A12FA001-AC4F-418D-AE19-62706E023703}">
-                      <ahyp:hlinkClr xmlns:ahyp="http://schemas.microsoft.com/office/drawing/2018/hyperlinkcolor" val="tx"/>
-                    </a:ext>
-                  </a:extLst>
-                </a:hlinkClick>
-              </a:rPr>
-              <a:t>drive.google.com/drive/folders/1CSJt9yyZX...</a:t>
-            </a:r>
-            <a:endParaRPr lang="en-US" sz="1100" dirty="0"/>
-          </a:p>
-        </p:txBody>
-      </p:sp>
-      <p:sp>
-        <p:nvSpPr>
-          <p:cNvPr id="20" name="Text 16"/>
-          <p:cNvSpPr/>
-          <p:nvPr/>
-        </p:nvSpPr>
-        <p:spPr>
-          <a:xfrm>
-            <a:off x="7132320" y="2395728"/>
-            <a:ext cx="4434840" cy="228600"/>
-          </a:xfrm>
-          <a:prstGeom prst="rect">
-            <a:avLst/>
-          </a:prstGeom>
-          <a:noFill/>
-          <a:ln/>
-        </p:spPr>
-        <p:txBody>
-          <a:bodyPr wrap="square" lIns="0" tIns="0" rIns="0" bIns="0" rtlCol="0" anchor="ctr"/>
-          <a:lstStyle/>
-          <a:p>
-            <a:pPr marL="0" indent="0">
-              <a:buNone/>
-            </a:pPr>
-            <a:r>
-              <a:rPr lang="en-US" sz="900" i="1" dirty="0">
-                <a:solidFill>
-                  <a:srgbClr val="94A3B8"/>
-                </a:solidFill>
-                <a:latin typeface="Calibri" pitchFamily="34" charset="0"/>
-                <a:ea typeface="Calibri" pitchFamily="34" charset="-122"/>
-                <a:cs typeface="Calibri" pitchFamily="34" charset="-120"/>
-              </a:rPr>
-              <a:t>Raw audio · cleaned segments · transcripts · 5 dialects · ~4.7 hrs</a:t>
-            </a:r>
-            <a:endParaRPr lang="en-US" sz="900" dirty="0"/>
-          </a:p>
-        </p:txBody>
-      </p:sp>
-      <p:sp>
-        <p:nvSpPr>
-          <p:cNvPr id="21" name="Shape 17"/>
-          <p:cNvSpPr/>
-          <p:nvPr/>
-        </p:nvSpPr>
-        <p:spPr>
-          <a:xfrm>
-            <a:off x="502920" y="2880360"/>
-            <a:ext cx="3703320" cy="3520440"/>
-          </a:xfrm>
-          <a:prstGeom prst="rect">
-            <a:avLst/>
-          </a:prstGeom>
-          <a:solidFill>
-            <a:srgbClr val="FFFFFF"/>
-          </a:solidFill>
-          <a:ln w="9525">
-            <a:solidFill>
-              <a:srgbClr val="E2E8F0"/>
-            </a:solidFill>
-            <a:prstDash val="solid"/>
-          </a:ln>
-        </p:spPr>
-      </p:sp>
-      <p:sp>
-        <p:nvSpPr>
-          <p:cNvPr id="22" name="Shape 18"/>
-          <p:cNvSpPr/>
-          <p:nvPr/>
-        </p:nvSpPr>
-        <p:spPr>
-          <a:xfrm>
-            <a:off x="502920" y="2880360"/>
-            <a:ext cx="3703320" cy="45720"/>
-          </a:xfrm>
-          <a:prstGeom prst="rect">
-            <a:avLst/>
-          </a:prstGeom>
-          <a:solidFill>
-            <a:srgbClr val="0D9488"/>
-          </a:solidFill>
-          <a:ln/>
-        </p:spPr>
-      </p:sp>
-      <p:sp>
-        <p:nvSpPr>
-          <p:cNvPr id="23" name="Shape 19"/>
-          <p:cNvSpPr/>
-          <p:nvPr/>
-        </p:nvSpPr>
-        <p:spPr>
-          <a:xfrm>
-            <a:off x="731520" y="3081528"/>
-            <a:ext cx="502920" cy="502920"/>
-          </a:xfrm>
-          <a:prstGeom prst="ellipse">
-            <a:avLst/>
-          </a:prstGeom>
-          <a:solidFill>
-            <a:srgbClr val="ECFDF5"/>
-          </a:solidFill>
-          <a:ln/>
-        </p:spPr>
-      </p:sp>
-      <p:pic>
-        <p:nvPicPr>
-          <p:cNvPr id="24" name="Image 2" descr="preencoded.png"/>
-          <p:cNvPicPr>
-            <a:picLocks noChangeAspect="1"/>
-          </p:cNvPicPr>
-          <p:nvPr/>
-        </p:nvPicPr>
-        <p:blipFill>
-          <a:blip r:embed="rId7"/>
-          <a:stretch>
-            <a:fillRect/>
-          </a:stretch>
-        </p:blipFill>
-        <p:spPr>
-          <a:xfrm>
-            <a:off x="832104" y="3182112"/>
-            <a:ext cx="301752" cy="301752"/>
-          </a:xfrm>
-          <a:prstGeom prst="rect">
-            <a:avLst/>
-          </a:prstGeom>
-        </p:spPr>
-      </p:pic>
-      <p:sp>
-        <p:nvSpPr>
-          <p:cNvPr id="25" name="Text 20"/>
-          <p:cNvSpPr/>
-          <p:nvPr/>
-        </p:nvSpPr>
-        <p:spPr>
-          <a:xfrm>
-            <a:off x="1371600" y="3172968"/>
-            <a:ext cx="2743200" cy="320040"/>
-          </a:xfrm>
-          <a:prstGeom prst="rect">
-            <a:avLst/>
-          </a:prstGeom>
-          <a:noFill/>
-          <a:ln/>
-        </p:spPr>
-        <p:txBody>
-          <a:bodyPr wrap="square" lIns="0" tIns="0" rIns="0" bIns="0" rtlCol="0" anchor="ctr"/>
-          <a:lstStyle/>
-          <a:p>
-            <a:pPr marL="0" indent="0">
-              <a:buNone/>
-            </a:pPr>
-            <a:r>
-              <a:rPr lang="en-US" sz="1000" b="1" kern="0" spc="300" dirty="0">
-                <a:solidFill>
-                  <a:srgbClr val="0D9488"/>
-                </a:solidFill>
-                <a:latin typeface="Calibri" pitchFamily="34" charset="0"/>
-                <a:ea typeface="Calibri" pitchFamily="34" charset="-122"/>
-                <a:cs typeface="Calibri" pitchFamily="34" charset="-120"/>
-              </a:rPr>
-              <a:t>ASR FOUNDATIONS</a:t>
-            </a:r>
-            <a:endParaRPr lang="en-US" sz="1000" dirty="0"/>
-          </a:p>
-        </p:txBody>
-      </p:sp>
-      <p:sp>
-        <p:nvSpPr>
-          <p:cNvPr id="26" name="Shape 21"/>
-          <p:cNvSpPr/>
-          <p:nvPr/>
-        </p:nvSpPr>
-        <p:spPr>
-          <a:xfrm>
-            <a:off x="731520" y="3721608"/>
-            <a:ext cx="3246120" cy="10973"/>
-          </a:xfrm>
-          <a:prstGeom prst="rect">
-            <a:avLst/>
-          </a:prstGeom>
-          <a:solidFill>
-            <a:srgbClr val="E2E8F0"/>
-          </a:solidFill>
-          <a:ln/>
-        </p:spPr>
-      </p:sp>
-      <p:sp>
-        <p:nvSpPr>
-          <p:cNvPr id="27" name="Text 22"/>
-          <p:cNvSpPr/>
-          <p:nvPr/>
-        </p:nvSpPr>
-        <p:spPr>
-          <a:xfrm>
-            <a:off x="731520" y="3840480"/>
-            <a:ext cx="3246120" cy="256032"/>
-          </a:xfrm>
-          <a:prstGeom prst="rect">
-            <a:avLst/>
-          </a:prstGeom>
-          <a:noFill/>
-          <a:ln/>
-        </p:spPr>
-        <p:txBody>
-          <a:bodyPr wrap="square" lIns="0" tIns="0" rIns="0" bIns="0" rtlCol="0" anchor="t"/>
-          <a:lstStyle/>
-          <a:p>
-            <a:pPr marL="0" indent="0">
-              <a:buNone/>
-            </a:pPr>
-            <a:r>
-              <a:rPr lang="en-US" sz="1000" b="1" dirty="0">
-                <a:solidFill>
-                  <a:srgbClr val="0F2747"/>
-                </a:solidFill>
-                <a:latin typeface="Calibri" pitchFamily="34" charset="0"/>
-                <a:ea typeface="Calibri" pitchFamily="34" charset="-122"/>
-                <a:cs typeface="Calibri" pitchFamily="34" charset="-120"/>
-              </a:rPr>
-              <a:t>Whisper — robust large-scale speech recognition</a:t>
-            </a:r>
-            <a:endParaRPr lang="en-US" sz="1000" dirty="0"/>
-          </a:p>
-        </p:txBody>
-      </p:sp>
-      <p:sp>
-        <p:nvSpPr>
-          <p:cNvPr id="28" name="Text 23"/>
-          <p:cNvSpPr/>
-          <p:nvPr/>
-        </p:nvSpPr>
-        <p:spPr>
-          <a:xfrm>
-            <a:off x="731520" y="4114800"/>
-            <a:ext cx="3246120" cy="292608"/>
-          </a:xfrm>
-          <a:prstGeom prst="rect">
-            <a:avLst/>
-          </a:prstGeom>
-          <a:noFill/>
-          <a:ln/>
-        </p:spPr>
-        <p:txBody>
-          <a:bodyPr wrap="square" lIns="0" tIns="0" rIns="0" bIns="0" rtlCol="0" anchor="t"/>
-          <a:lstStyle/>
-          <a:p>
-            <a:pPr marL="0" indent="0">
-              <a:buNone/>
-            </a:pPr>
-            <a:r>
-              <a:rPr lang="en-US" sz="850" i="1" dirty="0">
-                <a:solidFill>
-                  <a:srgbClr val="475569"/>
-                </a:solidFill>
-                <a:latin typeface="Calibri" pitchFamily="34" charset="0"/>
-                <a:ea typeface="Calibri" pitchFamily="34" charset="-122"/>
-                <a:cs typeface="Calibri" pitchFamily="34" charset="-120"/>
-              </a:rPr>
-              <a:t>Radford et al., OpenAI · 2023</a:t>
-            </a:r>
-            <a:r>
-              <a:rPr lang="en-US" sz="850" dirty="0">
-                <a:solidFill>
-                  <a:srgbClr val="94A3B8"/>
-                </a:solidFill>
-                <a:latin typeface="Calibri" pitchFamily="34" charset="0"/>
-                <a:ea typeface="Calibri" pitchFamily="34" charset="-122"/>
-                <a:cs typeface="Calibri" pitchFamily="34" charset="-120"/>
-              </a:rPr>
-              <a:t>  ·  </a:t>
-            </a:r>
-            <a:r>
-              <a:rPr lang="en-US" sz="850" dirty="0">
-                <a:solidFill>
-                  <a:srgbClr val="0D9488"/>
-                </a:solidFill>
-                <a:latin typeface="Calibri" pitchFamily="34" charset="0"/>
-                <a:ea typeface="Calibri" pitchFamily="34" charset="-122"/>
-                <a:cs typeface="Calibri" pitchFamily="34" charset="-120"/>
-              </a:rPr>
-              <a:t>arxiv.org/abs/2212.04356</a:t>
-            </a:r>
-            <a:endParaRPr lang="en-US" sz="850" dirty="0"/>
-          </a:p>
-        </p:txBody>
-      </p:sp>
-      <p:sp>
-        <p:nvSpPr>
-          <p:cNvPr id="29" name="Text 24"/>
-          <p:cNvSpPr/>
-          <p:nvPr/>
-        </p:nvSpPr>
-        <p:spPr>
-          <a:xfrm>
-            <a:off x="731520" y="4462272"/>
-            <a:ext cx="3246120" cy="256032"/>
-          </a:xfrm>
-          <a:prstGeom prst="rect">
-            <a:avLst/>
-          </a:prstGeom>
-          <a:noFill/>
-          <a:ln/>
-        </p:spPr>
-        <p:txBody>
-          <a:bodyPr wrap="square" lIns="0" tIns="0" rIns="0" bIns="0" rtlCol="0" anchor="t"/>
-          <a:lstStyle/>
-          <a:p>
-            <a:pPr marL="0" indent="0">
-              <a:buNone/>
-            </a:pPr>
-            <a:r>
-              <a:rPr lang="en-US" sz="1000" b="1" dirty="0">
-                <a:solidFill>
-                  <a:srgbClr val="0F2747"/>
-                </a:solidFill>
-                <a:latin typeface="Calibri" pitchFamily="34" charset="0"/>
-                <a:ea typeface="Calibri" pitchFamily="34" charset="-122"/>
-                <a:cs typeface="Calibri" pitchFamily="34" charset="-120"/>
-              </a:rPr>
-              <a:t>MMS — speech for 1000+ languages</a:t>
-            </a:r>
-            <a:endParaRPr lang="en-US" sz="1000" dirty="0"/>
-          </a:p>
-        </p:txBody>
-      </p:sp>
-      <p:sp>
-        <p:nvSpPr>
-          <p:cNvPr id="30" name="Text 25"/>
-          <p:cNvSpPr/>
-          <p:nvPr/>
-        </p:nvSpPr>
-        <p:spPr>
-          <a:xfrm>
-            <a:off x="731520" y="4736592"/>
-            <a:ext cx="3246120" cy="292608"/>
-          </a:xfrm>
-          <a:prstGeom prst="rect">
-            <a:avLst/>
-          </a:prstGeom>
-          <a:noFill/>
-          <a:ln/>
-        </p:spPr>
-        <p:txBody>
-          <a:bodyPr wrap="square" lIns="0" tIns="0" rIns="0" bIns="0" rtlCol="0" anchor="t"/>
-          <a:lstStyle/>
-          <a:p>
-            <a:pPr marL="0" indent="0">
-              <a:buNone/>
-            </a:pPr>
-            <a:r>
-              <a:rPr lang="en-US" sz="850" i="1" dirty="0">
-                <a:solidFill>
-                  <a:srgbClr val="475569"/>
-                </a:solidFill>
-                <a:latin typeface="Calibri" pitchFamily="34" charset="0"/>
-                <a:ea typeface="Calibri" pitchFamily="34" charset="-122"/>
-                <a:cs typeface="Calibri" pitchFamily="34" charset="-120"/>
-              </a:rPr>
-              <a:t>Pratap et al., Meta AI · 2023</a:t>
-            </a:r>
-            <a:r>
-              <a:rPr lang="en-US" sz="850" dirty="0">
-                <a:solidFill>
-                  <a:srgbClr val="94A3B8"/>
-                </a:solidFill>
-                <a:latin typeface="Calibri" pitchFamily="34" charset="0"/>
-                <a:ea typeface="Calibri" pitchFamily="34" charset="-122"/>
-                <a:cs typeface="Calibri" pitchFamily="34" charset="-120"/>
-              </a:rPr>
-              <a:t>  ·  </a:t>
-            </a:r>
-            <a:r>
-              <a:rPr lang="en-US" sz="850" dirty="0">
-                <a:solidFill>
-                  <a:srgbClr val="0D9488"/>
-                </a:solidFill>
-                <a:latin typeface="Calibri" pitchFamily="34" charset="0"/>
-                <a:ea typeface="Calibri" pitchFamily="34" charset="-122"/>
-                <a:cs typeface="Calibri" pitchFamily="34" charset="-120"/>
-              </a:rPr>
-              <a:t>arxiv.org/abs/2305.13516</a:t>
-            </a:r>
-            <a:endParaRPr lang="en-US" sz="850" dirty="0"/>
-          </a:p>
-        </p:txBody>
-      </p:sp>
-      <p:sp>
-        <p:nvSpPr>
-          <p:cNvPr id="31" name="Text 26"/>
-          <p:cNvSpPr/>
-          <p:nvPr/>
-        </p:nvSpPr>
-        <p:spPr>
-          <a:xfrm>
-            <a:off x="731520" y="5084064"/>
-            <a:ext cx="3246120" cy="256032"/>
-          </a:xfrm>
-          <a:prstGeom prst="rect">
-            <a:avLst/>
-          </a:prstGeom>
-          <a:noFill/>
-          <a:ln/>
-        </p:spPr>
-        <p:txBody>
-          <a:bodyPr wrap="square" lIns="0" tIns="0" rIns="0" bIns="0" rtlCol="0" anchor="t"/>
-          <a:lstStyle/>
-          <a:p>
-            <a:pPr marL="0" indent="0">
-              <a:buNone/>
-            </a:pPr>
-            <a:r>
-              <a:rPr lang="en-US" sz="1000" b="1" dirty="0">
-                <a:solidFill>
-                  <a:srgbClr val="0F2747"/>
-                </a:solidFill>
-                <a:latin typeface="Calibri" pitchFamily="34" charset="0"/>
-                <a:ea typeface="Calibri" pitchFamily="34" charset="-122"/>
-                <a:cs typeface="Calibri" pitchFamily="34" charset="-120"/>
-              </a:rPr>
-              <a:t>Wav2Vec 2.0 — self-supervised speech</a:t>
-            </a:r>
-            <a:endParaRPr lang="en-US" sz="1000" dirty="0"/>
-          </a:p>
-        </p:txBody>
-      </p:sp>
-      <p:sp>
-        <p:nvSpPr>
-          <p:cNvPr id="32" name="Text 27"/>
-          <p:cNvSpPr/>
-          <p:nvPr/>
-        </p:nvSpPr>
-        <p:spPr>
-          <a:xfrm>
-            <a:off x="731520" y="5358384"/>
-            <a:ext cx="3246120" cy="292608"/>
-          </a:xfrm>
-          <a:prstGeom prst="rect">
-            <a:avLst/>
-          </a:prstGeom>
-          <a:noFill/>
-          <a:ln/>
-        </p:spPr>
-        <p:txBody>
-          <a:bodyPr wrap="square" lIns="0" tIns="0" rIns="0" bIns="0" rtlCol="0" anchor="t"/>
-          <a:lstStyle/>
-          <a:p>
-            <a:pPr marL="0" indent="0">
-              <a:buNone/>
-            </a:pPr>
-            <a:r>
-              <a:rPr lang="en-US" sz="850" i="1" dirty="0">
-                <a:solidFill>
-                  <a:srgbClr val="475569"/>
-                </a:solidFill>
-                <a:latin typeface="Calibri" pitchFamily="34" charset="0"/>
-                <a:ea typeface="Calibri" pitchFamily="34" charset="-122"/>
-                <a:cs typeface="Calibri" pitchFamily="34" charset="-120"/>
-              </a:rPr>
-              <a:t>Baevski et al., Meta · 2020</a:t>
-            </a:r>
-            <a:r>
-              <a:rPr lang="en-US" sz="850" dirty="0">
-                <a:solidFill>
-                  <a:srgbClr val="94A3B8"/>
-                </a:solidFill>
-                <a:latin typeface="Calibri" pitchFamily="34" charset="0"/>
-                <a:ea typeface="Calibri" pitchFamily="34" charset="-122"/>
-                <a:cs typeface="Calibri" pitchFamily="34" charset="-120"/>
-              </a:rPr>
-              <a:t>  ·  </a:t>
-            </a:r>
-            <a:r>
-              <a:rPr lang="en-US" sz="850" dirty="0">
-                <a:solidFill>
-                  <a:srgbClr val="0D9488"/>
-                </a:solidFill>
-                <a:latin typeface="Calibri" pitchFamily="34" charset="0"/>
-                <a:ea typeface="Calibri" pitchFamily="34" charset="-122"/>
-                <a:cs typeface="Calibri" pitchFamily="34" charset="-120"/>
-              </a:rPr>
-              <a:t>arxiv.org/abs/2006.11477</a:t>
-            </a:r>
-            <a:endParaRPr lang="en-US" sz="850" dirty="0"/>
-          </a:p>
-        </p:txBody>
-      </p:sp>
-      <p:sp>
-        <p:nvSpPr>
-          <p:cNvPr id="33" name="Text 28"/>
-          <p:cNvSpPr/>
-          <p:nvPr/>
-        </p:nvSpPr>
-        <p:spPr>
-          <a:xfrm>
-            <a:off x="731520" y="5705856"/>
-            <a:ext cx="3246120" cy="256032"/>
-          </a:xfrm>
-          <a:prstGeom prst="rect">
-            <a:avLst/>
-          </a:prstGeom>
-          <a:noFill/>
-          <a:ln/>
-        </p:spPr>
-        <p:txBody>
-          <a:bodyPr wrap="square" lIns="0" tIns="0" rIns="0" bIns="0" rtlCol="0" anchor="t"/>
-          <a:lstStyle/>
-          <a:p>
-            <a:pPr marL="0" indent="0">
-              <a:buNone/>
-            </a:pPr>
-            <a:r>
-              <a:rPr lang="en-US" sz="1000" b="1" dirty="0">
-                <a:solidFill>
-                  <a:srgbClr val="0F2747"/>
-                </a:solidFill>
-                <a:latin typeface="Calibri" pitchFamily="34" charset="0"/>
-                <a:ea typeface="Calibri" pitchFamily="34" charset="-122"/>
-                <a:cs typeface="Calibri" pitchFamily="34" charset="-120"/>
-              </a:rPr>
-              <a:t>Qwen2-Audio · Qwen3-ASR (audio LLMs)</a:t>
-            </a:r>
-            <a:endParaRPr lang="en-US" sz="1000" dirty="0"/>
-          </a:p>
-        </p:txBody>
-      </p:sp>
-      <p:sp>
-        <p:nvSpPr>
-          <p:cNvPr id="34" name="Text 29"/>
-          <p:cNvSpPr/>
-          <p:nvPr/>
-        </p:nvSpPr>
-        <p:spPr>
-          <a:xfrm>
-            <a:off x="731520" y="5980176"/>
-            <a:ext cx="3246120" cy="292608"/>
-          </a:xfrm>
-          <a:prstGeom prst="rect">
-            <a:avLst/>
-          </a:prstGeom>
-          <a:noFill/>
-          <a:ln/>
-        </p:spPr>
-        <p:txBody>
-          <a:bodyPr wrap="square" lIns="0" tIns="0" rIns="0" bIns="0" rtlCol="0" anchor="t"/>
-          <a:lstStyle/>
-          <a:p>
-            <a:pPr marL="0" indent="0">
-              <a:buNone/>
-            </a:pPr>
-            <a:r>
-              <a:rPr lang="en-US" sz="850" i="1" dirty="0">
-                <a:solidFill>
-                  <a:srgbClr val="475569"/>
-                </a:solidFill>
-                <a:latin typeface="Calibri" pitchFamily="34" charset="0"/>
-                <a:ea typeface="Calibri" pitchFamily="34" charset="-122"/>
-                <a:cs typeface="Calibri" pitchFamily="34" charset="-120"/>
-              </a:rPr>
-              <a:t>Chu et al., Alibaba · 2024</a:t>
-            </a:r>
-            <a:r>
-              <a:rPr lang="en-US" sz="850" dirty="0">
-                <a:solidFill>
-                  <a:srgbClr val="94A3B8"/>
-                </a:solidFill>
-                <a:latin typeface="Calibri" pitchFamily="34" charset="0"/>
-                <a:ea typeface="Calibri" pitchFamily="34" charset="-122"/>
-                <a:cs typeface="Calibri" pitchFamily="34" charset="-120"/>
-              </a:rPr>
-              <a:t>  ·  </a:t>
-            </a:r>
-            <a:r>
-              <a:rPr lang="en-US" sz="850" dirty="0">
-                <a:solidFill>
-                  <a:srgbClr val="0D9488"/>
-                </a:solidFill>
-                <a:latin typeface="Calibri" pitchFamily="34" charset="0"/>
-                <a:ea typeface="Calibri" pitchFamily="34" charset="-122"/>
-                <a:cs typeface="Calibri" pitchFamily="34" charset="-120"/>
-              </a:rPr>
-              <a:t>arxiv.org/abs/2407.10759</a:t>
-            </a:r>
-            <a:endParaRPr lang="en-US" sz="850" dirty="0"/>
-          </a:p>
-        </p:txBody>
-      </p:sp>
-      <p:sp>
-        <p:nvSpPr>
-          <p:cNvPr id="35" name="Shape 30"/>
-          <p:cNvSpPr/>
-          <p:nvPr/>
-        </p:nvSpPr>
-        <p:spPr>
-          <a:xfrm>
-            <a:off x="4274820" y="2880360"/>
-            <a:ext cx="3703320" cy="3520440"/>
-          </a:xfrm>
-          <a:prstGeom prst="rect">
-            <a:avLst/>
-          </a:prstGeom>
-          <a:solidFill>
-            <a:srgbClr val="FFFFFF"/>
-          </a:solidFill>
-          <a:ln w="9525">
-            <a:solidFill>
-              <a:srgbClr val="E2E8F0"/>
-            </a:solidFill>
-            <a:prstDash val="solid"/>
-          </a:ln>
-        </p:spPr>
-      </p:sp>
-      <p:sp>
-        <p:nvSpPr>
-          <p:cNvPr id="36" name="Shape 31"/>
-          <p:cNvSpPr/>
-          <p:nvPr/>
-        </p:nvSpPr>
-        <p:spPr>
-          <a:xfrm>
-            <a:off x="4274820" y="2880360"/>
-            <a:ext cx="3703320" cy="45720"/>
-          </a:xfrm>
-          <a:prstGeom prst="rect">
-            <a:avLst/>
-          </a:prstGeom>
-          <a:solidFill>
-            <a:srgbClr val="0D9488"/>
-          </a:solidFill>
-          <a:ln/>
-        </p:spPr>
-      </p:sp>
-      <p:sp>
-        <p:nvSpPr>
-          <p:cNvPr id="37" name="Shape 32"/>
-          <p:cNvSpPr/>
-          <p:nvPr/>
-        </p:nvSpPr>
-        <p:spPr>
-          <a:xfrm>
-            <a:off x="4503420" y="3081528"/>
-            <a:ext cx="502920" cy="502920"/>
-          </a:xfrm>
-          <a:prstGeom prst="ellipse">
-            <a:avLst/>
-          </a:prstGeom>
-          <a:solidFill>
-            <a:srgbClr val="ECFDF5"/>
-          </a:solidFill>
-          <a:ln/>
-        </p:spPr>
-      </p:sp>
-      <p:pic>
-        <p:nvPicPr>
-          <p:cNvPr id="38" name="Image 3" descr="preencoded.png"/>
-          <p:cNvPicPr>
-            <a:picLocks noChangeAspect="1"/>
-          </p:cNvPicPr>
-          <p:nvPr/>
-        </p:nvPicPr>
-        <p:blipFill>
-          <a:blip r:embed="rId8"/>
-          <a:stretch>
-            <a:fillRect/>
-          </a:stretch>
-        </p:blipFill>
-        <p:spPr>
-          <a:xfrm>
-            <a:off x="4604004" y="3182112"/>
-            <a:ext cx="301752" cy="301752"/>
-          </a:xfrm>
-          <a:prstGeom prst="rect">
-            <a:avLst/>
-          </a:prstGeom>
-        </p:spPr>
-      </p:pic>
-      <p:sp>
-        <p:nvSpPr>
-          <p:cNvPr id="39" name="Text 33"/>
-          <p:cNvSpPr/>
-          <p:nvPr/>
-        </p:nvSpPr>
-        <p:spPr>
-          <a:xfrm>
-            <a:off x="5143500" y="3172968"/>
-            <a:ext cx="2743200" cy="320040"/>
-          </a:xfrm>
-          <a:prstGeom prst="rect">
-            <a:avLst/>
-          </a:prstGeom>
-          <a:noFill/>
-          <a:ln/>
-        </p:spPr>
-        <p:txBody>
-          <a:bodyPr wrap="square" lIns="0" tIns="0" rIns="0" bIns="0" rtlCol="0" anchor="ctr"/>
-          <a:lstStyle/>
-          <a:p>
-            <a:pPr marL="0" indent="0">
-              <a:buNone/>
-            </a:pPr>
-            <a:r>
-              <a:rPr lang="en-US" sz="1000" b="1" kern="0" spc="300" dirty="0">
-                <a:solidFill>
-                  <a:srgbClr val="0D9488"/>
-                </a:solidFill>
-                <a:latin typeface="Calibri" pitchFamily="34" charset="0"/>
-                <a:ea typeface="Calibri" pitchFamily="34" charset="-122"/>
-                <a:cs typeface="Calibri" pitchFamily="34" charset="-120"/>
-              </a:rPr>
-              <a:t>BENGALI SPEECH RESOURCES</a:t>
-            </a:r>
-            <a:endParaRPr lang="en-US" sz="1000" dirty="0"/>
-          </a:p>
-        </p:txBody>
-      </p:sp>
-      <p:sp>
-        <p:nvSpPr>
-          <p:cNvPr id="40" name="Shape 34"/>
-          <p:cNvSpPr/>
-          <p:nvPr/>
-        </p:nvSpPr>
-        <p:spPr>
-          <a:xfrm>
-            <a:off x="4503420" y="3721608"/>
-            <a:ext cx="3246120" cy="10973"/>
-          </a:xfrm>
-          <a:prstGeom prst="rect">
-            <a:avLst/>
-          </a:prstGeom>
-          <a:solidFill>
-            <a:srgbClr val="E2E8F0"/>
-          </a:solidFill>
-          <a:ln/>
-        </p:spPr>
-      </p:sp>
-      <p:sp>
-        <p:nvSpPr>
-          <p:cNvPr id="41" name="Text 35"/>
-          <p:cNvSpPr/>
-          <p:nvPr/>
-        </p:nvSpPr>
-        <p:spPr>
-          <a:xfrm>
-            <a:off x="4503420" y="3840480"/>
-            <a:ext cx="3246120" cy="256032"/>
-          </a:xfrm>
-          <a:prstGeom prst="rect">
-            <a:avLst/>
-          </a:prstGeom>
-          <a:noFill/>
-          <a:ln/>
-        </p:spPr>
-        <p:txBody>
-          <a:bodyPr wrap="square" lIns="0" tIns="0" rIns="0" bIns="0" rtlCol="0" anchor="t"/>
-          <a:lstStyle/>
-          <a:p>
-            <a:pPr marL="0" indent="0">
-              <a:buNone/>
-            </a:pPr>
-            <a:r>
-              <a:rPr lang="en-US" sz="1000" b="1" dirty="0">
-                <a:solidFill>
-                  <a:srgbClr val="0F2747"/>
-                </a:solidFill>
-                <a:latin typeface="Calibri" pitchFamily="34" charset="0"/>
-                <a:ea typeface="Calibri" pitchFamily="34" charset="-122"/>
-                <a:cs typeface="Calibri" pitchFamily="34" charset="-120"/>
-              </a:rPr>
-              <a:t>OOD-Speech — Bangla OOD ASR dataset</a:t>
-            </a:r>
-            <a:endParaRPr lang="en-US" sz="1000" dirty="0"/>
-          </a:p>
-        </p:txBody>
-      </p:sp>
-      <p:sp>
-        <p:nvSpPr>
-          <p:cNvPr id="42" name="Text 36"/>
-          <p:cNvSpPr/>
-          <p:nvPr/>
-        </p:nvSpPr>
-        <p:spPr>
-          <a:xfrm>
-            <a:off x="4503420" y="4114800"/>
-            <a:ext cx="3246120" cy="292608"/>
-          </a:xfrm>
-          <a:prstGeom prst="rect">
-            <a:avLst/>
-          </a:prstGeom>
-          <a:noFill/>
-          <a:ln/>
-        </p:spPr>
-        <p:txBody>
-          <a:bodyPr wrap="square" lIns="0" tIns="0" rIns="0" bIns="0" rtlCol="0" anchor="t"/>
-          <a:lstStyle/>
-          <a:p>
-            <a:pPr marL="0" indent="0">
-              <a:buNone/>
-            </a:pPr>
-            <a:r>
-              <a:rPr lang="en-US" sz="850" i="1" dirty="0">
-                <a:solidFill>
-                  <a:srgbClr val="475569"/>
-                </a:solidFill>
-                <a:latin typeface="Calibri" pitchFamily="34" charset="0"/>
-                <a:ea typeface="Calibri" pitchFamily="34" charset="-122"/>
-                <a:cs typeface="Calibri" pitchFamily="34" charset="-120"/>
-              </a:rPr>
-              <a:t>Rakib et al., Interspeech · 2023</a:t>
-            </a:r>
-            <a:r>
-              <a:rPr lang="en-US" sz="850" dirty="0">
-                <a:solidFill>
-                  <a:srgbClr val="94A3B8"/>
-                </a:solidFill>
-                <a:latin typeface="Calibri" pitchFamily="34" charset="0"/>
-                <a:ea typeface="Calibri" pitchFamily="34" charset="-122"/>
-                <a:cs typeface="Calibri" pitchFamily="34" charset="-120"/>
-              </a:rPr>
-              <a:t>  ·  </a:t>
-            </a:r>
-            <a:r>
-              <a:rPr lang="en-US" sz="850" dirty="0">
-                <a:solidFill>
-                  <a:srgbClr val="0D9488"/>
-                </a:solidFill>
-                <a:latin typeface="Calibri" pitchFamily="34" charset="0"/>
-                <a:ea typeface="Calibri" pitchFamily="34" charset="-122"/>
-                <a:cs typeface="Calibri" pitchFamily="34" charset="-120"/>
-              </a:rPr>
-              <a:t>arxiv.org/abs/2305.09688</a:t>
-            </a:r>
-            <a:endParaRPr lang="en-US" sz="850" dirty="0"/>
-          </a:p>
-        </p:txBody>
-      </p:sp>
-      <p:sp>
-        <p:nvSpPr>
-          <p:cNvPr id="43" name="Text 37"/>
-          <p:cNvSpPr/>
-          <p:nvPr/>
-        </p:nvSpPr>
-        <p:spPr>
-          <a:xfrm>
-            <a:off x="4503420" y="4462272"/>
-            <a:ext cx="3246120" cy="256032"/>
-          </a:xfrm>
-          <a:prstGeom prst="rect">
-            <a:avLst/>
-          </a:prstGeom>
-          <a:noFill/>
-          <a:ln/>
-        </p:spPr>
-        <p:txBody>
-          <a:bodyPr wrap="square" lIns="0" tIns="0" rIns="0" bIns="0" rtlCol="0" anchor="t"/>
-          <a:lstStyle/>
-          <a:p>
-            <a:pPr marL="0" indent="0">
-              <a:buNone/>
-            </a:pPr>
-            <a:r>
-              <a:rPr lang="en-US" sz="1000" b="1" dirty="0">
-                <a:solidFill>
-                  <a:srgbClr val="0F2747"/>
-                </a:solidFill>
-                <a:latin typeface="Calibri" pitchFamily="34" charset="0"/>
-                <a:ea typeface="Calibri" pitchFamily="34" charset="-122"/>
-                <a:cs typeface="Calibri" pitchFamily="34" charset="-120"/>
-              </a:rPr>
-              <a:t>Bengali AI Speech Recognition</a:t>
-            </a:r>
-            <a:endParaRPr lang="en-US" sz="1000" dirty="0"/>
-          </a:p>
-        </p:txBody>
-      </p:sp>
-      <p:sp>
-        <p:nvSpPr>
-          <p:cNvPr id="44" name="Text 38"/>
-          <p:cNvSpPr/>
-          <p:nvPr/>
-        </p:nvSpPr>
-        <p:spPr>
-          <a:xfrm>
-            <a:off x="4503420" y="4736592"/>
-            <a:ext cx="3246120" cy="292608"/>
-          </a:xfrm>
-          <a:prstGeom prst="rect">
-            <a:avLst/>
-          </a:prstGeom>
-          <a:noFill/>
-          <a:ln/>
-        </p:spPr>
-        <p:txBody>
-          <a:bodyPr wrap="square" lIns="0" tIns="0" rIns="0" bIns="0" rtlCol="0" anchor="t"/>
-          <a:lstStyle/>
-          <a:p>
-            <a:pPr marL="0" indent="0">
-              <a:buNone/>
-            </a:pPr>
-            <a:r>
-              <a:rPr lang="en-US" sz="850" i="1" dirty="0">
-                <a:solidFill>
-                  <a:srgbClr val="475569"/>
-                </a:solidFill>
-                <a:latin typeface="Calibri" pitchFamily="34" charset="0"/>
-                <a:ea typeface="Calibri" pitchFamily="34" charset="-122"/>
-                <a:cs typeface="Calibri" pitchFamily="34" charset="-120"/>
-              </a:rPr>
-              <a:t>Bengali.AI · Kaggle · 2023</a:t>
-            </a:r>
-            <a:r>
-              <a:rPr lang="en-US" sz="850" dirty="0">
-                <a:solidFill>
-                  <a:srgbClr val="94A3B8"/>
-                </a:solidFill>
-                <a:latin typeface="Calibri" pitchFamily="34" charset="0"/>
-                <a:ea typeface="Calibri" pitchFamily="34" charset="-122"/>
-                <a:cs typeface="Calibri" pitchFamily="34" charset="-120"/>
-              </a:rPr>
-              <a:t>  ·  </a:t>
-            </a:r>
-            <a:r>
-              <a:rPr lang="en-US" sz="850" dirty="0">
-                <a:solidFill>
-                  <a:srgbClr val="0D9488"/>
-                </a:solidFill>
-                <a:latin typeface="Calibri" pitchFamily="34" charset="0"/>
-                <a:ea typeface="Calibri" pitchFamily="34" charset="-122"/>
-                <a:cs typeface="Calibri" pitchFamily="34" charset="-120"/>
-              </a:rPr>
-              <a:t>huggingface.co/bengaliai</a:t>
-            </a:r>
-            <a:endParaRPr lang="en-US" sz="850" dirty="0"/>
-          </a:p>
-        </p:txBody>
-      </p:sp>
-      <p:sp>
-        <p:nvSpPr>
-          <p:cNvPr id="45" name="Text 39"/>
-          <p:cNvSpPr/>
-          <p:nvPr/>
-        </p:nvSpPr>
-        <p:spPr>
-          <a:xfrm>
-            <a:off x="4503420" y="5084064"/>
-            <a:ext cx="3246120" cy="256032"/>
-          </a:xfrm>
-          <a:prstGeom prst="rect">
-            <a:avLst/>
-          </a:prstGeom>
-          <a:noFill/>
-          <a:ln/>
-        </p:spPr>
-        <p:txBody>
-          <a:bodyPr wrap="square" lIns="0" tIns="0" rIns="0" bIns="0" rtlCol="0" anchor="t"/>
-          <a:lstStyle/>
-          <a:p>
-            <a:pPr marL="0" indent="0">
-              <a:buNone/>
-            </a:pPr>
-            <a:r>
-              <a:rPr lang="en-US" sz="1000" b="1" dirty="0">
-                <a:solidFill>
-                  <a:srgbClr val="0F2747"/>
-                </a:solidFill>
-                <a:latin typeface="Calibri" pitchFamily="34" charset="0"/>
-                <a:ea typeface="Calibri" pitchFamily="34" charset="-122"/>
-                <a:cs typeface="Calibri" pitchFamily="34" charset="-120"/>
-              </a:rPr>
-              <a:t>Bengali Common Voice (crowdsourced)</a:t>
-            </a:r>
-            <a:endParaRPr lang="en-US" sz="1000" dirty="0"/>
-          </a:p>
-        </p:txBody>
-      </p:sp>
-      <p:sp>
-        <p:nvSpPr>
-          <p:cNvPr id="46" name="Text 40"/>
-          <p:cNvSpPr/>
-          <p:nvPr/>
-        </p:nvSpPr>
-        <p:spPr>
-          <a:xfrm>
-            <a:off x="4503420" y="5358384"/>
-            <a:ext cx="3246120" cy="292608"/>
-          </a:xfrm>
-          <a:prstGeom prst="rect">
-            <a:avLst/>
-          </a:prstGeom>
-          <a:noFill/>
-          <a:ln/>
-        </p:spPr>
-        <p:txBody>
-          <a:bodyPr wrap="square" lIns="0" tIns="0" rIns="0" bIns="0" rtlCol="0" anchor="t"/>
-          <a:lstStyle/>
-          <a:p>
-            <a:pPr marL="0" indent="0">
-              <a:buNone/>
-            </a:pPr>
-            <a:r>
-              <a:rPr lang="en-US" sz="850" i="1" dirty="0">
-                <a:solidFill>
-                  <a:srgbClr val="475569"/>
-                </a:solidFill>
-                <a:latin typeface="Calibri" pitchFamily="34" charset="0"/>
-                <a:ea typeface="Calibri" pitchFamily="34" charset="-122"/>
-                <a:cs typeface="Calibri" pitchFamily="34" charset="-120"/>
-              </a:rPr>
-              <a:t>Mozilla Foundation</a:t>
-            </a:r>
-            <a:r>
-              <a:rPr lang="en-US" sz="850" dirty="0">
-                <a:solidFill>
-                  <a:srgbClr val="94A3B8"/>
-                </a:solidFill>
-                <a:latin typeface="Calibri" pitchFamily="34" charset="0"/>
-                <a:ea typeface="Calibri" pitchFamily="34" charset="-122"/>
-                <a:cs typeface="Calibri" pitchFamily="34" charset="-120"/>
-              </a:rPr>
-              <a:t>  ·  </a:t>
-            </a:r>
-            <a:r>
-              <a:rPr lang="en-US" sz="850" dirty="0">
-                <a:solidFill>
-                  <a:srgbClr val="0D9488"/>
-                </a:solidFill>
-                <a:latin typeface="Calibri" pitchFamily="34" charset="0"/>
-                <a:ea typeface="Calibri" pitchFamily="34" charset="-122"/>
-                <a:cs typeface="Calibri" pitchFamily="34" charset="-120"/>
-              </a:rPr>
-              <a:t>commonvoice.mozilla.org/bn</a:t>
-            </a:r>
-            <a:endParaRPr lang="en-US" sz="850" dirty="0"/>
-          </a:p>
-        </p:txBody>
-      </p:sp>
-      <p:sp>
-        <p:nvSpPr>
-          <p:cNvPr id="47" name="Text 41"/>
-          <p:cNvSpPr/>
-          <p:nvPr/>
-        </p:nvSpPr>
-        <p:spPr>
-          <a:xfrm>
-            <a:off x="4503420" y="5705856"/>
-            <a:ext cx="3246120" cy="256032"/>
-          </a:xfrm>
-          <a:prstGeom prst="rect">
-            <a:avLst/>
-          </a:prstGeom>
-          <a:noFill/>
-          <a:ln/>
-        </p:spPr>
-        <p:txBody>
-          <a:bodyPr wrap="square" lIns="0" tIns="0" rIns="0" bIns="0" rtlCol="0" anchor="t"/>
-          <a:lstStyle/>
-          <a:p>
-            <a:pPr marL="0" indent="0">
-              <a:buNone/>
-            </a:pPr>
-            <a:r>
-              <a:rPr lang="en-US" sz="1000" b="1" dirty="0">
-                <a:solidFill>
-                  <a:srgbClr val="0F2747"/>
-                </a:solidFill>
-                <a:latin typeface="Calibri" pitchFamily="34" charset="0"/>
-                <a:ea typeface="Calibri" pitchFamily="34" charset="-122"/>
-                <a:cs typeface="Calibri" pitchFamily="34" charset="-120"/>
-              </a:rPr>
-              <a:t>IndicWav2Vec / Vakyansh</a:t>
-            </a:r>
-            <a:endParaRPr lang="en-US" sz="1000" dirty="0"/>
-          </a:p>
-        </p:txBody>
-      </p:sp>
-      <p:sp>
-        <p:nvSpPr>
-          <p:cNvPr id="48" name="Text 42"/>
-          <p:cNvSpPr/>
-          <p:nvPr/>
-        </p:nvSpPr>
-        <p:spPr>
-          <a:xfrm>
-            <a:off x="4503420" y="5980176"/>
-            <a:ext cx="3246120" cy="292608"/>
-          </a:xfrm>
-          <a:prstGeom prst="rect">
-            <a:avLst/>
-          </a:prstGeom>
-          <a:noFill/>
-          <a:ln/>
-        </p:spPr>
-        <p:txBody>
-          <a:bodyPr wrap="square" lIns="0" tIns="0" rIns="0" bIns="0" rtlCol="0" anchor="t"/>
-          <a:lstStyle/>
-          <a:p>
-            <a:pPr marL="0" indent="0">
-              <a:buNone/>
-            </a:pPr>
-            <a:r>
-              <a:rPr lang="en-US" sz="850" i="1" dirty="0">
-                <a:solidFill>
-                  <a:srgbClr val="475569"/>
-                </a:solidFill>
-                <a:latin typeface="Calibri" pitchFamily="34" charset="0"/>
-                <a:ea typeface="Calibri" pitchFamily="34" charset="-122"/>
-                <a:cs typeface="Calibri" pitchFamily="34" charset="-120"/>
-              </a:rPr>
-              <a:t>AI4Bharat</a:t>
-            </a:r>
-            <a:r>
-              <a:rPr lang="en-US" sz="850" dirty="0">
-                <a:solidFill>
-                  <a:srgbClr val="94A3B8"/>
-                </a:solidFill>
-                <a:latin typeface="Calibri" pitchFamily="34" charset="0"/>
-                <a:ea typeface="Calibri" pitchFamily="34" charset="-122"/>
-                <a:cs typeface="Calibri" pitchFamily="34" charset="-120"/>
-              </a:rPr>
-              <a:t>  ·  </a:t>
-            </a:r>
-            <a:r>
-              <a:rPr lang="en-US" sz="850" dirty="0">
-                <a:solidFill>
-                  <a:srgbClr val="0D9488"/>
-                </a:solidFill>
-                <a:latin typeface="Calibri" pitchFamily="34" charset="0"/>
-                <a:ea typeface="Calibri" pitchFamily="34" charset="-122"/>
-                <a:cs typeface="Calibri" pitchFamily="34" charset="-120"/>
-              </a:rPr>
-              <a:t>github.com/AI4Bharat</a:t>
-            </a:r>
-            <a:endParaRPr lang="en-US" sz="850" dirty="0"/>
-          </a:p>
-        </p:txBody>
-      </p:sp>
-      <p:sp>
-        <p:nvSpPr>
-          <p:cNvPr id="49" name="Shape 43"/>
-          <p:cNvSpPr/>
-          <p:nvPr/>
-        </p:nvSpPr>
-        <p:spPr>
-          <a:xfrm>
-            <a:off x="8046720" y="2880360"/>
-            <a:ext cx="3703320" cy="3520440"/>
-          </a:xfrm>
-          <a:prstGeom prst="rect">
-            <a:avLst/>
-          </a:prstGeom>
-          <a:solidFill>
-            <a:srgbClr val="FFFFFF"/>
-          </a:solidFill>
-          <a:ln w="9525">
-            <a:solidFill>
-              <a:srgbClr val="E2E8F0"/>
-            </a:solidFill>
-            <a:prstDash val="solid"/>
-          </a:ln>
-        </p:spPr>
-      </p:sp>
-      <p:sp>
-        <p:nvSpPr>
-          <p:cNvPr id="50" name="Shape 44"/>
-          <p:cNvSpPr/>
-          <p:nvPr/>
-        </p:nvSpPr>
-        <p:spPr>
-          <a:xfrm>
-            <a:off x="8046720" y="2880360"/>
-            <a:ext cx="3703320" cy="45720"/>
-          </a:xfrm>
-          <a:prstGeom prst="rect">
-            <a:avLst/>
-          </a:prstGeom>
-          <a:solidFill>
-            <a:srgbClr val="0D9488"/>
-          </a:solidFill>
-          <a:ln/>
-        </p:spPr>
-      </p:sp>
-      <p:sp>
-        <p:nvSpPr>
-          <p:cNvPr id="51" name="Shape 45"/>
-          <p:cNvSpPr/>
-          <p:nvPr/>
-        </p:nvSpPr>
-        <p:spPr>
-          <a:xfrm>
-            <a:off x="8275320" y="3081528"/>
-            <a:ext cx="502920" cy="502920"/>
-          </a:xfrm>
-          <a:prstGeom prst="ellipse">
-            <a:avLst/>
-          </a:prstGeom>
-          <a:solidFill>
-            <a:srgbClr val="ECFDF5"/>
-          </a:solidFill>
-          <a:ln/>
-        </p:spPr>
-      </p:sp>
-      <p:pic>
-        <p:nvPicPr>
-          <p:cNvPr id="52" name="Image 4" descr="preencoded.png"/>
-          <p:cNvPicPr>
-            <a:picLocks noChangeAspect="1"/>
-          </p:cNvPicPr>
-          <p:nvPr/>
-        </p:nvPicPr>
-        <p:blipFill>
-          <a:blip r:embed="rId9"/>
-          <a:stretch>
-            <a:fillRect/>
-          </a:stretch>
-        </p:blipFill>
-        <p:spPr>
-          <a:xfrm>
-            <a:off x="8375904" y="3182112"/>
-            <a:ext cx="301752" cy="301752"/>
-          </a:xfrm>
-          <a:prstGeom prst="rect">
-            <a:avLst/>
-          </a:prstGeom>
-        </p:spPr>
-      </p:pic>
-      <p:sp>
-        <p:nvSpPr>
-          <p:cNvPr id="53" name="Text 46"/>
-          <p:cNvSpPr/>
-          <p:nvPr/>
-        </p:nvSpPr>
-        <p:spPr>
-          <a:xfrm>
-            <a:off x="8915400" y="3172968"/>
-            <a:ext cx="2743200" cy="320040"/>
-          </a:xfrm>
-          <a:prstGeom prst="rect">
-            <a:avLst/>
-          </a:prstGeom>
-          <a:noFill/>
-          <a:ln/>
-        </p:spPr>
-        <p:txBody>
-          <a:bodyPr wrap="square" lIns="0" tIns="0" rIns="0" bIns="0" rtlCol="0" anchor="ctr"/>
-          <a:lstStyle/>
-          <a:p>
-            <a:pPr marL="0" indent="0">
-              <a:buNone/>
-            </a:pPr>
-            <a:r>
-              <a:rPr lang="en-US" sz="1000" b="1" kern="0" spc="300" dirty="0">
-                <a:solidFill>
-                  <a:srgbClr val="0D9488"/>
-                </a:solidFill>
-                <a:latin typeface="Calibri" pitchFamily="34" charset="0"/>
-                <a:ea typeface="Calibri" pitchFamily="34" charset="-122"/>
-                <a:cs typeface="Calibri" pitchFamily="34" charset="-120"/>
-              </a:rPr>
-              <a:t>MEDICAL NLP / AI SCRIBES</a:t>
-            </a:r>
-            <a:endParaRPr lang="en-US" sz="1000" dirty="0"/>
-          </a:p>
-        </p:txBody>
-      </p:sp>
-      <p:sp>
-        <p:nvSpPr>
-          <p:cNvPr id="54" name="Shape 47"/>
-          <p:cNvSpPr/>
-          <p:nvPr/>
-        </p:nvSpPr>
-        <p:spPr>
-          <a:xfrm>
-            <a:off x="8275320" y="3721608"/>
-            <a:ext cx="3246120" cy="10973"/>
-          </a:xfrm>
-          <a:prstGeom prst="rect">
-            <a:avLst/>
-          </a:prstGeom>
-          <a:solidFill>
-            <a:srgbClr val="E2E8F0"/>
-          </a:solidFill>
-          <a:ln/>
-        </p:spPr>
-      </p:sp>
-      <p:sp>
-        <p:nvSpPr>
-          <p:cNvPr id="55" name="Text 48"/>
-          <p:cNvSpPr/>
-          <p:nvPr/>
-        </p:nvSpPr>
-        <p:spPr>
-          <a:xfrm>
-            <a:off x="8275320" y="3840480"/>
-            <a:ext cx="3246120" cy="256032"/>
-          </a:xfrm>
-          <a:prstGeom prst="rect">
-            <a:avLst/>
-          </a:prstGeom>
-          <a:noFill/>
-          <a:ln/>
-        </p:spPr>
-        <p:txBody>
-          <a:bodyPr wrap="square" lIns="0" tIns="0" rIns="0" bIns="0" rtlCol="0" anchor="t"/>
-          <a:lstStyle/>
-          <a:p>
-            <a:pPr marL="0" indent="0">
-              <a:buNone/>
-            </a:pPr>
-            <a:r>
-              <a:rPr lang="en-US" sz="1000" b="1" dirty="0">
-                <a:solidFill>
-                  <a:srgbClr val="0F2747"/>
-                </a:solidFill>
-                <a:latin typeface="Calibri" pitchFamily="34" charset="0"/>
-                <a:ea typeface="Calibri" pitchFamily="34" charset="-122"/>
-                <a:cs typeface="Calibri" pitchFamily="34" charset="-120"/>
-              </a:rPr>
-              <a:t>BanglaBERT — Bangla LM benchmarks</a:t>
-            </a:r>
-            <a:endParaRPr lang="en-US" sz="1000" dirty="0"/>
-          </a:p>
-        </p:txBody>
-      </p:sp>
-      <p:sp>
-        <p:nvSpPr>
-          <p:cNvPr id="56" name="Text 49"/>
-          <p:cNvSpPr/>
-          <p:nvPr/>
-        </p:nvSpPr>
-        <p:spPr>
-          <a:xfrm>
-            <a:off x="8275320" y="4114800"/>
-            <a:ext cx="3246120" cy="292608"/>
-          </a:xfrm>
-          <a:prstGeom prst="rect">
-            <a:avLst/>
-          </a:prstGeom>
-          <a:noFill/>
-          <a:ln/>
-        </p:spPr>
-        <p:txBody>
-          <a:bodyPr wrap="square" lIns="0" tIns="0" rIns="0" bIns="0" rtlCol="0" anchor="t"/>
-          <a:lstStyle/>
-          <a:p>
-            <a:pPr marL="0" indent="0">
-              <a:buNone/>
-            </a:pPr>
-            <a:r>
-              <a:rPr lang="en-US" sz="850" i="1" dirty="0">
-                <a:solidFill>
-                  <a:srgbClr val="475569"/>
-                </a:solidFill>
-                <a:latin typeface="Calibri" pitchFamily="34" charset="0"/>
-                <a:ea typeface="Calibri" pitchFamily="34" charset="-122"/>
-                <a:cs typeface="Calibri" pitchFamily="34" charset="-120"/>
-              </a:rPr>
-              <a:t>Bhattacharjee et al., NAACL · 2022</a:t>
-            </a:r>
-            <a:r>
-              <a:rPr lang="en-US" sz="850" dirty="0">
-                <a:solidFill>
-                  <a:srgbClr val="94A3B8"/>
-                </a:solidFill>
-                <a:latin typeface="Calibri" pitchFamily="34" charset="0"/>
-                <a:ea typeface="Calibri" pitchFamily="34" charset="-122"/>
-                <a:cs typeface="Calibri" pitchFamily="34" charset="-120"/>
-              </a:rPr>
-              <a:t>  ·  </a:t>
-            </a:r>
-            <a:r>
-              <a:rPr lang="en-US" sz="850" dirty="0">
-                <a:solidFill>
-                  <a:srgbClr val="0D9488"/>
-                </a:solidFill>
-                <a:latin typeface="Calibri" pitchFamily="34" charset="0"/>
-                <a:ea typeface="Calibri" pitchFamily="34" charset="-122"/>
-                <a:cs typeface="Calibri" pitchFamily="34" charset="-120"/>
-              </a:rPr>
-              <a:t>github.com/csebuetnlp/banglabert</a:t>
-            </a:r>
-            <a:endParaRPr lang="en-US" sz="850" dirty="0"/>
-          </a:p>
-        </p:txBody>
-      </p:sp>
-      <p:sp>
-        <p:nvSpPr>
-          <p:cNvPr id="57" name="Text 50"/>
-          <p:cNvSpPr/>
-          <p:nvPr/>
-        </p:nvSpPr>
-        <p:spPr>
-          <a:xfrm>
-            <a:off x="8275320" y="4462272"/>
-            <a:ext cx="3246120" cy="256032"/>
-          </a:xfrm>
-          <a:prstGeom prst="rect">
-            <a:avLst/>
-          </a:prstGeom>
-          <a:noFill/>
-          <a:ln/>
-        </p:spPr>
-        <p:txBody>
-          <a:bodyPr wrap="square" lIns="0" tIns="0" rIns="0" bIns="0" rtlCol="0" anchor="t"/>
-          <a:lstStyle/>
-          <a:p>
-            <a:pPr marL="0" indent="0">
-              <a:buNone/>
-            </a:pPr>
-            <a:r>
-              <a:rPr lang="en-US" sz="1000" b="1" dirty="0">
-                <a:solidFill>
-                  <a:srgbClr val="0F2747"/>
-                </a:solidFill>
-                <a:latin typeface="Calibri" pitchFamily="34" charset="0"/>
-                <a:ea typeface="Calibri" pitchFamily="34" charset="-122"/>
-                <a:cs typeface="Calibri" pitchFamily="34" charset="-120"/>
-              </a:rPr>
-              <a:t>BioBERT — biomedical language model</a:t>
-            </a:r>
-            <a:endParaRPr lang="en-US" sz="1000" dirty="0"/>
-          </a:p>
-        </p:txBody>
-      </p:sp>
-      <p:sp>
-        <p:nvSpPr>
-          <p:cNvPr id="58" name="Text 51"/>
-          <p:cNvSpPr/>
-          <p:nvPr/>
-        </p:nvSpPr>
-        <p:spPr>
-          <a:xfrm>
-            <a:off x="8275320" y="4736592"/>
-            <a:ext cx="3246120" cy="292608"/>
-          </a:xfrm>
-          <a:prstGeom prst="rect">
-            <a:avLst/>
-          </a:prstGeom>
-          <a:noFill/>
-          <a:ln/>
-        </p:spPr>
-        <p:txBody>
-          <a:bodyPr wrap="square" lIns="0" tIns="0" rIns="0" bIns="0" rtlCol="0" anchor="t"/>
-          <a:lstStyle/>
-          <a:p>
-            <a:pPr marL="0" indent="0">
-              <a:buNone/>
-            </a:pPr>
-            <a:r>
-              <a:rPr lang="en-US" sz="850" i="1" dirty="0">
-                <a:solidFill>
-                  <a:srgbClr val="475569"/>
-                </a:solidFill>
-                <a:latin typeface="Calibri" pitchFamily="34" charset="0"/>
-                <a:ea typeface="Calibri" pitchFamily="34" charset="-122"/>
-                <a:cs typeface="Calibri" pitchFamily="34" charset="-120"/>
-              </a:rPr>
-              <a:t>Lee et al., Bioinformatics · 2020</a:t>
-            </a:r>
-            <a:r>
-              <a:rPr lang="en-US" sz="850" dirty="0">
-                <a:solidFill>
-                  <a:srgbClr val="94A3B8"/>
-                </a:solidFill>
-                <a:latin typeface="Calibri" pitchFamily="34" charset="0"/>
-                <a:ea typeface="Calibri" pitchFamily="34" charset="-122"/>
-                <a:cs typeface="Calibri" pitchFamily="34" charset="-120"/>
-              </a:rPr>
-              <a:t>  ·  </a:t>
-            </a:r>
-            <a:r>
-              <a:rPr lang="en-US" sz="850" dirty="0">
-                <a:solidFill>
-                  <a:srgbClr val="0D9488"/>
-                </a:solidFill>
-                <a:latin typeface="Calibri" pitchFamily="34" charset="0"/>
-                <a:ea typeface="Calibri" pitchFamily="34" charset="-122"/>
-                <a:cs typeface="Calibri" pitchFamily="34" charset="-120"/>
-              </a:rPr>
-              <a:t>arxiv.org/abs/1901.08746</a:t>
-            </a:r>
-            <a:endParaRPr lang="en-US" sz="850" dirty="0"/>
-          </a:p>
-        </p:txBody>
-      </p:sp>
-      <p:sp>
-        <p:nvSpPr>
-          <p:cNvPr id="59" name="Text 52"/>
-          <p:cNvSpPr/>
-          <p:nvPr/>
-        </p:nvSpPr>
-        <p:spPr>
-          <a:xfrm>
-            <a:off x="8275320" y="5084064"/>
-            <a:ext cx="3246120" cy="256032"/>
-          </a:xfrm>
-          <a:prstGeom prst="rect">
-            <a:avLst/>
-          </a:prstGeom>
-          <a:noFill/>
-          <a:ln/>
-        </p:spPr>
-        <p:txBody>
-          <a:bodyPr wrap="square" lIns="0" tIns="0" rIns="0" bIns="0" rtlCol="0" anchor="t"/>
-          <a:lstStyle/>
-          <a:p>
-            <a:pPr marL="0" indent="0">
-              <a:buNone/>
-            </a:pPr>
-            <a:r>
-              <a:rPr lang="en-US" sz="1000" b="1" dirty="0">
-                <a:solidFill>
-                  <a:srgbClr val="0F2747"/>
-                </a:solidFill>
-                <a:latin typeface="Calibri" pitchFamily="34" charset="0"/>
-                <a:ea typeface="Calibri" pitchFamily="34" charset="-122"/>
-                <a:cs typeface="Calibri" pitchFamily="34" charset="-120"/>
-              </a:rPr>
-              <a:t>ClinicalBERT — clinical-note embeddings</a:t>
-            </a:r>
-            <a:endParaRPr lang="en-US" sz="1000" dirty="0"/>
-          </a:p>
-        </p:txBody>
-      </p:sp>
-      <p:sp>
-        <p:nvSpPr>
-          <p:cNvPr id="60" name="Text 53"/>
-          <p:cNvSpPr/>
-          <p:nvPr/>
-        </p:nvSpPr>
-        <p:spPr>
-          <a:xfrm>
-            <a:off x="8275320" y="5358384"/>
-            <a:ext cx="3246120" cy="292608"/>
-          </a:xfrm>
-          <a:prstGeom prst="rect">
-            <a:avLst/>
-          </a:prstGeom>
-          <a:noFill/>
-          <a:ln/>
-        </p:spPr>
-        <p:txBody>
-          <a:bodyPr wrap="square" lIns="0" tIns="0" rIns="0" bIns="0" rtlCol="0" anchor="t"/>
-          <a:lstStyle/>
-          <a:p>
-            <a:pPr marL="0" indent="0">
-              <a:buNone/>
-            </a:pPr>
-            <a:r>
-              <a:rPr lang="en-US" sz="850" i="1" dirty="0">
-                <a:solidFill>
-                  <a:srgbClr val="475569"/>
-                </a:solidFill>
-                <a:latin typeface="Calibri" pitchFamily="34" charset="0"/>
-                <a:ea typeface="Calibri" pitchFamily="34" charset="-122"/>
-                <a:cs typeface="Calibri" pitchFamily="34" charset="-120"/>
-              </a:rPr>
-              <a:t>Alsentzer et al. · 2019</a:t>
-            </a:r>
-            <a:r>
-              <a:rPr lang="en-US" sz="850" dirty="0">
-                <a:solidFill>
-                  <a:srgbClr val="94A3B8"/>
-                </a:solidFill>
-                <a:latin typeface="Calibri" pitchFamily="34" charset="0"/>
-                <a:ea typeface="Calibri" pitchFamily="34" charset="-122"/>
-                <a:cs typeface="Calibri" pitchFamily="34" charset="-120"/>
-              </a:rPr>
-              <a:t>  ·  </a:t>
-            </a:r>
-            <a:r>
-              <a:rPr lang="en-US" sz="850" dirty="0">
-                <a:solidFill>
-                  <a:srgbClr val="0D9488"/>
-                </a:solidFill>
-                <a:latin typeface="Calibri" pitchFamily="34" charset="0"/>
-                <a:ea typeface="Calibri" pitchFamily="34" charset="-122"/>
-                <a:cs typeface="Calibri" pitchFamily="34" charset="-120"/>
-              </a:rPr>
-              <a:t>arxiv.org/abs/1904.03323</a:t>
-            </a:r>
-            <a:endParaRPr lang="en-US" sz="850" dirty="0"/>
-          </a:p>
-        </p:txBody>
-      </p:sp>
-      <p:sp>
-        <p:nvSpPr>
-          <p:cNvPr id="61" name="Text 54"/>
-          <p:cNvSpPr/>
-          <p:nvPr/>
-        </p:nvSpPr>
-        <p:spPr>
-          <a:xfrm>
-            <a:off x="8275320" y="5705856"/>
-            <a:ext cx="3246120" cy="256032"/>
-          </a:xfrm>
-          <a:prstGeom prst="rect">
-            <a:avLst/>
-          </a:prstGeom>
-          <a:noFill/>
-          <a:ln/>
-        </p:spPr>
-        <p:txBody>
-          <a:bodyPr wrap="square" lIns="0" tIns="0" rIns="0" bIns="0" rtlCol="0" anchor="t"/>
-          <a:lstStyle/>
-          <a:p>
-            <a:pPr marL="0" indent="0">
-              <a:buNone/>
-            </a:pPr>
-            <a:r>
-              <a:rPr lang="en-US" sz="1000" b="1" dirty="0">
-                <a:solidFill>
-                  <a:srgbClr val="0F2747"/>
-                </a:solidFill>
-                <a:latin typeface="Calibri" pitchFamily="34" charset="0"/>
-                <a:ea typeface="Calibri" pitchFamily="34" charset="-122"/>
-                <a:cs typeface="Calibri" pitchFamily="34" charset="-120"/>
-              </a:rPr>
-              <a:t>AI clinical scribes (adjacent products)</a:t>
-            </a:r>
-            <a:endParaRPr lang="en-US" sz="1000" dirty="0"/>
-          </a:p>
-        </p:txBody>
-      </p:sp>
-      <p:sp>
-        <p:nvSpPr>
-          <p:cNvPr id="62" name="Text 55"/>
-          <p:cNvSpPr/>
-          <p:nvPr/>
-        </p:nvSpPr>
-        <p:spPr>
-          <a:xfrm>
-            <a:off x="8275320" y="5980176"/>
-            <a:ext cx="3246120" cy="292608"/>
-          </a:xfrm>
-          <a:prstGeom prst="rect">
-            <a:avLst/>
-          </a:prstGeom>
-          <a:noFill/>
-          <a:ln/>
-        </p:spPr>
-        <p:txBody>
-          <a:bodyPr wrap="square" lIns="0" tIns="0" rIns="0" bIns="0" rtlCol="0" anchor="t"/>
-          <a:lstStyle/>
-          <a:p>
-            <a:pPr marL="0" indent="0">
-              <a:buNone/>
-            </a:pPr>
-            <a:r>
-              <a:rPr lang="en-US" sz="850" i="1" dirty="0">
-                <a:solidFill>
-                  <a:srgbClr val="475569"/>
-                </a:solidFill>
-                <a:latin typeface="Calibri" pitchFamily="34" charset="0"/>
-                <a:ea typeface="Calibri" pitchFamily="34" charset="-122"/>
-                <a:cs typeface="Calibri" pitchFamily="34" charset="-120"/>
-              </a:rPr>
-              <a:t>Nuance DAX · DeepScribe · Abridge</a:t>
-            </a:r>
-            <a:r>
-              <a:rPr lang="en-US" sz="850" dirty="0">
-                <a:solidFill>
-                  <a:srgbClr val="94A3B8"/>
-                </a:solidFill>
-                <a:latin typeface="Calibri" pitchFamily="34" charset="0"/>
-                <a:ea typeface="Calibri" pitchFamily="34" charset="-122"/>
-                <a:cs typeface="Calibri" pitchFamily="34" charset="-120"/>
-              </a:rPr>
-              <a:t>  ·  </a:t>
-            </a:r>
-            <a:r>
-              <a:rPr lang="en-US" sz="850" dirty="0">
-                <a:solidFill>
-                  <a:srgbClr val="0D9488"/>
-                </a:solidFill>
-                <a:latin typeface="Calibri" pitchFamily="34" charset="0"/>
-                <a:ea typeface="Calibri" pitchFamily="34" charset="-122"/>
-                <a:cs typeface="Calibri" pitchFamily="34" charset="-120"/>
-              </a:rPr>
-              <a:t>(commercial · for context)</a:t>
-            </a:r>
-            <a:endParaRPr lang="en-US" sz="850" dirty="0"/>
           </a:p>
         </p:txBody>
       </p:sp>

</xml_diff>